<commit_message>
Update course materials: replace outdated presentation, remove obsolete LEIA-ME file, and enhance Rmd and HTML content for clarity.
</commit_message>
<xml_diff>
--- a/4. Inteligência Artificial e os Dados_Eder/Dados a base de toda IA no melhoramento.pptx
+++ b/4. Inteligência Artificial e os Dados_Eder/Dados a base de toda IA no melhoramento.pptx
@@ -256,12 +256,12 @@
   <pc:docChgLst>
     <pc:chgData name="Eder Silva" userId="9b7f41b4-798d-40cf-8f87-8e33ae7a0417" providerId="ADAL" clId="{DFF9E84E-5922-4F26-9EAD-8AB4E668133E}"/>
     <pc:docChg chg="mod modSld modMainMaster">
-      <pc:chgData name="Eder Silva" userId="9b7f41b4-798d-40cf-8f87-8e33ae7a0417" providerId="ADAL" clId="{DFF9E84E-5922-4F26-9EAD-8AB4E668133E}" dt="2026-10-20T12:21:31.999" v="3" actId="6549"/>
+      <pc:chgData name="Eder Silva" userId="9b7f41b4-798d-40cf-8f87-8e33ae7a0417" providerId="ADAL" clId="{DFF9E84E-5922-4F26-9EAD-8AB4E668133E}" dt="2026-10-26T11:35:50.709" v="5" actId="6549"/>
       <pc:docMkLst>
         <pc:docMk/>
       </pc:docMkLst>
       <pc:sldChg chg="modSp mod">
-        <pc:chgData name="Eder Silva" userId="9b7f41b4-798d-40cf-8f87-8e33ae7a0417" providerId="ADAL" clId="{DFF9E84E-5922-4F26-9EAD-8AB4E668133E}" dt="2026-10-20T12:21:31.999" v="3" actId="6549"/>
+        <pc:chgData name="Eder Silva" userId="9b7f41b4-798d-40cf-8f87-8e33ae7a0417" providerId="ADAL" clId="{DFF9E84E-5922-4F26-9EAD-8AB4E668133E}" dt="2026-10-26T11:35:50.709" v="5" actId="6549"/>
         <pc:sldMkLst>
           <pc:docMk/>
           <pc:sldMk cId="0" sldId="256"/>
@@ -275,7 +275,7 @@
           </ac:spMkLst>
         </pc:spChg>
         <pc:spChg chg="mod">
-          <ac:chgData name="Eder Silva" userId="9b7f41b4-798d-40cf-8f87-8e33ae7a0417" providerId="ADAL" clId="{DFF9E84E-5922-4F26-9EAD-8AB4E668133E}" dt="2026-10-20T12:04:59.323" v="0" actId="6549"/>
+          <ac:chgData name="Eder Silva" userId="9b7f41b4-798d-40cf-8f87-8e33ae7a0417" providerId="ADAL" clId="{DFF9E84E-5922-4F26-9EAD-8AB4E668133E}" dt="2026-10-26T11:35:50.709" v="5" actId="6549"/>
           <ac:spMkLst>
             <pc:docMk/>
             <pc:sldMk cId="0" sldId="256"/>
@@ -5154,7 +5154,7 @@
           </a:prstGeom>
           <a:extLst>
             <a:ext uri="{C572A759-6A51-4108-AA02-DFA0A04FC94B}">
-              <ma14:wrappingTextBoxFlag xmlns:ma14="http://schemas.microsoft.com/office/mac/drawingml/2011/main" xmlns="" val="0"/>
+              <ma14:wrappingTextBoxFlag xmlns="" xmlns:ma14="http://schemas.microsoft.com/office/mac/drawingml/2011/main" val="0"/>
             </a:ext>
           </a:extLst>
         </p:spPr>
@@ -5276,7 +5276,7 @@
           </a:prstGeom>
           <a:extLst>
             <a:ext uri="{C572A759-6A51-4108-AA02-DFA0A04FC94B}">
-              <ma14:wrappingTextBoxFlag xmlns:ma14="http://schemas.microsoft.com/office/mac/drawingml/2011/main" xmlns="" val="0"/>
+              <ma14:wrappingTextBoxFlag xmlns="" xmlns:ma14="http://schemas.microsoft.com/office/mac/drawingml/2011/main" val="0"/>
             </a:ext>
           </a:extLst>
         </p:spPr>
@@ -5354,7 +5354,7 @@
           </a:prstGeom>
           <a:extLst>
             <a:ext uri="{C572A759-6A51-4108-AA02-DFA0A04FC94B}">
-              <ma14:wrappingTextBoxFlag xmlns:ma14="http://schemas.microsoft.com/office/mac/drawingml/2011/main" xmlns="" val="0"/>
+              <ma14:wrappingTextBoxFlag xmlns="" xmlns:ma14="http://schemas.microsoft.com/office/mac/drawingml/2011/main" val="0"/>
             </a:ext>
           </a:extLst>
         </p:spPr>
@@ -8291,42 +8291,7 @@
                   <a:schemeClr val="tx2"/>
                 </a:solidFill>
               </a:rPr>
-              <a:t> 2 h · </a:t>
-            </a:r>
-            <a:r>
-              <a:rPr lang="en-US" sz="1500" b="1" dirty="0">
-                <a:solidFill>
-                  <a:schemeClr val="tx2"/>
-                </a:solidFill>
-              </a:rPr>
-              <a:t>Prática:</a:t>
-            </a:r>
-            <a:r>
-              <a:rPr lang="en-US" sz="1500" dirty="0">
-                <a:solidFill>
-                  <a:schemeClr val="tx2"/>
-                </a:solidFill>
-              </a:rPr>
-              <a:t> </a:t>
-            </a:r>
-            <a:r>
-              <a:rPr lang="en-US" sz="1380" dirty="0">
-                <a:solidFill>
-                  <a:schemeClr val="tx2"/>
-                </a:solidFill>
-                <a:latin typeface="Courier New" pitchFamily="34" charset="0"/>
-                <a:ea typeface="Courier New" pitchFamily="34" charset="-122"/>
-                <a:cs typeface="Courier New" pitchFamily="34" charset="-120"/>
-              </a:rPr>
-              <a:t>caderno.md</a:t>
-            </a:r>
-            <a:r>
-              <a:rPr lang="en-US" sz="1500" dirty="0">
-                <a:solidFill>
-                  <a:schemeClr val="tx2"/>
-                </a:solidFill>
-              </a:rPr>
-              <a:t> · </a:t>
+              <a:t> 2 h ·  </a:t>
             </a:r>
             <a:r>
               <a:rPr lang="en-US" sz="1500" b="1" dirty="0">
@@ -9871,7 +9836,7 @@
           </a:prstGeom>
           <a:extLst>
             <a:ext uri="{C572A759-6A51-4108-AA02-DFA0A04FC94B}">
-              <ma14:wrappingTextBoxFlag xmlns:ma14="http://schemas.microsoft.com/office/mac/drawingml/2011/main" xmlns="" val="0"/>
+              <ma14:wrappingTextBoxFlag xmlns="" xmlns:ma14="http://schemas.microsoft.com/office/mac/drawingml/2011/main" val="0"/>
             </a:ext>
           </a:extLst>
         </p:spPr>
@@ -11595,7 +11560,7 @@
           </a:prstGeom>
           <a:extLst>
             <a:ext uri="{C572A759-6A51-4108-AA02-DFA0A04FC94B}">
-              <ma14:wrappingTextBoxFlag xmlns:ma14="http://schemas.microsoft.com/office/mac/drawingml/2011/main" xmlns="" val="0"/>
+              <ma14:wrappingTextBoxFlag xmlns="" xmlns:ma14="http://schemas.microsoft.com/office/mac/drawingml/2011/main" val="0"/>
             </a:ext>
           </a:extLst>
         </p:spPr>
@@ -12202,7 +12167,7 @@
           </a:prstGeom>
           <a:extLst>
             <a:ext uri="{C572A759-6A51-4108-AA02-DFA0A04FC94B}">
-              <ma14:wrappingTextBoxFlag xmlns:ma14="http://schemas.microsoft.com/office/mac/drawingml/2011/main" xmlns="" val="0"/>
+              <ma14:wrappingTextBoxFlag xmlns="" xmlns:ma14="http://schemas.microsoft.com/office/mac/drawingml/2011/main" val="0"/>
             </a:ext>
           </a:extLst>
         </p:spPr>
@@ -13615,7 +13580,7 @@
           </a:prstGeom>
           <a:extLst>
             <a:ext uri="{C572A759-6A51-4108-AA02-DFA0A04FC94B}">
-              <ma14:wrappingTextBoxFlag xmlns:ma14="http://schemas.microsoft.com/office/mac/drawingml/2011/main" xmlns="" val="0"/>
+              <ma14:wrappingTextBoxFlag xmlns="" xmlns:ma14="http://schemas.microsoft.com/office/mac/drawingml/2011/main" val="0"/>
             </a:ext>
           </a:extLst>
         </p:spPr>
@@ -14320,7 +14285,7 @@
           </a:prstGeom>
           <a:extLst>
             <a:ext uri="{C572A759-6A51-4108-AA02-DFA0A04FC94B}">
-              <ma14:wrappingTextBoxFlag xmlns:ma14="http://schemas.microsoft.com/office/mac/drawingml/2011/main" xmlns="" val="0"/>
+              <ma14:wrappingTextBoxFlag xmlns="" xmlns:ma14="http://schemas.microsoft.com/office/mac/drawingml/2011/main" val="0"/>
             </a:ext>
           </a:extLst>
         </p:spPr>
@@ -14993,7 +14958,7 @@
           </a:prstGeom>
           <a:extLst>
             <a:ext uri="{C572A759-6A51-4108-AA02-DFA0A04FC94B}">
-              <ma14:wrappingTextBoxFlag xmlns:ma14="http://schemas.microsoft.com/office/mac/drawingml/2011/main" xmlns="" val="0"/>
+              <ma14:wrappingTextBoxFlag xmlns="" xmlns:ma14="http://schemas.microsoft.com/office/mac/drawingml/2011/main" val="0"/>
             </a:ext>
           </a:extLst>
         </p:spPr>
@@ -15965,7 +15930,7 @@
           </a:prstGeom>
           <a:extLst>
             <a:ext uri="{C572A759-6A51-4108-AA02-DFA0A04FC94B}">
-              <ma14:wrappingTextBoxFlag xmlns:ma14="http://schemas.microsoft.com/office/mac/drawingml/2011/main" xmlns="" val="0"/>
+              <ma14:wrappingTextBoxFlag xmlns="" xmlns:ma14="http://schemas.microsoft.com/office/mac/drawingml/2011/main" val="0"/>
             </a:ext>
           </a:extLst>
         </p:spPr>
@@ -16776,7 +16741,7 @@
           </a:prstGeom>
           <a:extLst>
             <a:ext uri="{C572A759-6A51-4108-AA02-DFA0A04FC94B}">
-              <ma14:wrappingTextBoxFlag xmlns:ma14="http://schemas.microsoft.com/office/mac/drawingml/2011/main" xmlns="" val="0"/>
+              <ma14:wrappingTextBoxFlag xmlns="" xmlns:ma14="http://schemas.microsoft.com/office/mac/drawingml/2011/main" val="0"/>
             </a:ext>
           </a:extLst>
         </p:spPr>
@@ -18021,7 +17986,7 @@
           </a:prstGeom>
           <a:extLst>
             <a:ext uri="{C572A759-6A51-4108-AA02-DFA0A04FC94B}">
-              <ma14:wrappingTextBoxFlag xmlns:ma14="http://schemas.microsoft.com/office/mac/drawingml/2011/main" xmlns="" val="0"/>
+              <ma14:wrappingTextBoxFlag xmlns="" xmlns:ma14="http://schemas.microsoft.com/office/mac/drawingml/2011/main" val="0"/>
             </a:ext>
           </a:extLst>
         </p:spPr>
@@ -18560,7 +18525,7 @@
           </a:prstGeom>
           <a:extLst>
             <a:ext uri="{C572A759-6A51-4108-AA02-DFA0A04FC94B}">
-              <ma14:wrappingTextBoxFlag xmlns:ma14="http://schemas.microsoft.com/office/mac/drawingml/2011/main" xmlns="" val="0"/>
+              <ma14:wrappingTextBoxFlag xmlns="" xmlns:ma14="http://schemas.microsoft.com/office/mac/drawingml/2011/main" val="0"/>
             </a:ext>
           </a:extLst>
         </p:spPr>
@@ -19740,7 +19705,7 @@
           </a:prstGeom>
           <a:extLst>
             <a:ext uri="{C572A759-6A51-4108-AA02-DFA0A04FC94B}">
-              <ma14:wrappingTextBoxFlag xmlns:ma14="http://schemas.microsoft.com/office/mac/drawingml/2011/main" xmlns="" val="0"/>
+              <ma14:wrappingTextBoxFlag xmlns="" xmlns:ma14="http://schemas.microsoft.com/office/mac/drawingml/2011/main" val="0"/>
             </a:ext>
           </a:extLst>
         </p:spPr>
@@ -20687,7 +20652,7 @@
           </a:prstGeom>
           <a:extLst>
             <a:ext uri="{C572A759-6A51-4108-AA02-DFA0A04FC94B}">
-              <ma14:wrappingTextBoxFlag xmlns:ma14="http://schemas.microsoft.com/office/mac/drawingml/2011/main" xmlns="" val="0"/>
+              <ma14:wrappingTextBoxFlag xmlns="" xmlns:ma14="http://schemas.microsoft.com/office/mac/drawingml/2011/main" val="0"/>
             </a:ext>
           </a:extLst>
         </p:spPr>
@@ -21098,7 +21063,7 @@
           </a:prstGeom>
           <a:extLst>
             <a:ext uri="{C572A759-6A51-4108-AA02-DFA0A04FC94B}">
-              <ma14:wrappingTextBoxFlag xmlns:ma14="http://schemas.microsoft.com/office/mac/drawingml/2011/main" xmlns="" val="0"/>
+              <ma14:wrappingTextBoxFlag xmlns="" xmlns:ma14="http://schemas.microsoft.com/office/mac/drawingml/2011/main" val="0"/>
             </a:ext>
           </a:extLst>
         </p:spPr>
@@ -21950,7 +21915,7 @@
           </a:prstGeom>
           <a:extLst>
             <a:ext uri="{C572A759-6A51-4108-AA02-DFA0A04FC94B}">
-              <ma14:wrappingTextBoxFlag xmlns:ma14="http://schemas.microsoft.com/office/mac/drawingml/2011/main" xmlns="" val="0"/>
+              <ma14:wrappingTextBoxFlag xmlns="" xmlns:ma14="http://schemas.microsoft.com/office/mac/drawingml/2011/main" val="0"/>
             </a:ext>
           </a:extLst>
         </p:spPr>
@@ -22186,7 +22151,7 @@
           </a:prstGeom>
           <a:extLst>
             <a:ext uri="{C572A759-6A51-4108-AA02-DFA0A04FC94B}">
-              <ma14:wrappingTextBoxFlag xmlns:ma14="http://schemas.microsoft.com/office/mac/drawingml/2011/main" xmlns="" val="0"/>
+              <ma14:wrappingTextBoxFlag xmlns="" xmlns:ma14="http://schemas.microsoft.com/office/mac/drawingml/2011/main" val="0"/>
             </a:ext>
           </a:extLst>
         </p:spPr>
@@ -23224,7 +23189,7 @@
           </a:prstGeom>
           <a:extLst>
             <a:ext uri="{C572A759-6A51-4108-AA02-DFA0A04FC94B}">
-              <ma14:wrappingTextBoxFlag xmlns:ma14="http://schemas.microsoft.com/office/mac/drawingml/2011/main" xmlns="" val="0"/>
+              <ma14:wrappingTextBoxFlag xmlns="" xmlns:ma14="http://schemas.microsoft.com/office/mac/drawingml/2011/main" val="0"/>
             </a:ext>
           </a:extLst>
         </p:spPr>
@@ -24951,7 +24916,7 @@
           </a:prstGeom>
           <a:extLst>
             <a:ext uri="{C572A759-6A51-4108-AA02-DFA0A04FC94B}">
-              <ma14:wrappingTextBoxFlag xmlns:ma14="http://schemas.microsoft.com/office/mac/drawingml/2011/main" xmlns="" val="0"/>
+              <ma14:wrappingTextBoxFlag xmlns="" xmlns:ma14="http://schemas.microsoft.com/office/mac/drawingml/2011/main" val="0"/>
             </a:ext>
           </a:extLst>
         </p:spPr>
@@ -25346,7 +25311,7 @@
           </a:prstGeom>
           <a:extLst>
             <a:ext uri="{C572A759-6A51-4108-AA02-DFA0A04FC94B}">
-              <ma14:wrappingTextBoxFlag xmlns:ma14="http://schemas.microsoft.com/office/mac/drawingml/2011/main" xmlns="" val="0"/>
+              <ma14:wrappingTextBoxFlag xmlns="" xmlns:ma14="http://schemas.microsoft.com/office/mac/drawingml/2011/main" val="0"/>
             </a:ext>
           </a:extLst>
         </p:spPr>
@@ -26643,7 +26608,7 @@
           </a:prstGeom>
           <a:extLst>
             <a:ext uri="{C572A759-6A51-4108-AA02-DFA0A04FC94B}">
-              <ma14:wrappingTextBoxFlag xmlns:ma14="http://schemas.microsoft.com/office/mac/drawingml/2011/main" xmlns="" val="0"/>
+              <ma14:wrappingTextBoxFlag xmlns="" xmlns:ma14="http://schemas.microsoft.com/office/mac/drawingml/2011/main" val="0"/>
             </a:ext>
           </a:extLst>
         </p:spPr>
@@ -27146,7 +27111,7 @@
           </a:prstGeom>
           <a:extLst>
             <a:ext uri="{C572A759-6A51-4108-AA02-DFA0A04FC94B}">
-              <ma14:wrappingTextBoxFlag xmlns:ma14="http://schemas.microsoft.com/office/mac/drawingml/2011/main" xmlns="" val="0"/>
+              <ma14:wrappingTextBoxFlag xmlns="" xmlns:ma14="http://schemas.microsoft.com/office/mac/drawingml/2011/main" val="0"/>
             </a:ext>
           </a:extLst>
         </p:spPr>
@@ -29048,7 +29013,7 @@
           </a:prstGeom>
           <a:extLst>
             <a:ext uri="{C572A759-6A51-4108-AA02-DFA0A04FC94B}">
-              <ma14:wrappingTextBoxFlag xmlns:ma14="http://schemas.microsoft.com/office/mac/drawingml/2011/main" xmlns="" val="0"/>
+              <ma14:wrappingTextBoxFlag xmlns="" xmlns:ma14="http://schemas.microsoft.com/office/mac/drawingml/2011/main" val="0"/>
             </a:ext>
           </a:extLst>
         </p:spPr>
@@ -29284,7 +29249,7 @@
           </a:prstGeom>
           <a:extLst>
             <a:ext uri="{C572A759-6A51-4108-AA02-DFA0A04FC94B}">
-              <ma14:wrappingTextBoxFlag xmlns:ma14="http://schemas.microsoft.com/office/mac/drawingml/2011/main" xmlns="" val="0"/>
+              <ma14:wrappingTextBoxFlag xmlns="" xmlns:ma14="http://schemas.microsoft.com/office/mac/drawingml/2011/main" val="0"/>
             </a:ext>
           </a:extLst>
         </p:spPr>
@@ -29803,7 +29768,7 @@
           </a:prstGeom>
           <a:extLst>
             <a:ext uri="{C572A759-6A51-4108-AA02-DFA0A04FC94B}">
-              <ma14:wrappingTextBoxFlag xmlns:ma14="http://schemas.microsoft.com/office/mac/drawingml/2011/main" xmlns="" val="0"/>
+              <ma14:wrappingTextBoxFlag xmlns="" xmlns:ma14="http://schemas.microsoft.com/office/mac/drawingml/2011/main" val="0"/>
             </a:ext>
           </a:extLst>
         </p:spPr>
@@ -30889,7 +30854,7 @@
           </a:prstGeom>
           <a:extLst>
             <a:ext uri="{C572A759-6A51-4108-AA02-DFA0A04FC94B}">
-              <ma14:wrappingTextBoxFlag xmlns:ma14="http://schemas.microsoft.com/office/mac/drawingml/2011/main" xmlns="" val="0"/>
+              <ma14:wrappingTextBoxFlag xmlns="" xmlns:ma14="http://schemas.microsoft.com/office/mac/drawingml/2011/main" val="0"/>
             </a:ext>
           </a:extLst>
         </p:spPr>
@@ -32148,7 +32113,7 @@
           </a:prstGeom>
           <a:extLst>
             <a:ext uri="{C572A759-6A51-4108-AA02-DFA0A04FC94B}">
-              <ma14:wrappingTextBoxFlag xmlns:ma14="http://schemas.microsoft.com/office/mac/drawingml/2011/main" xmlns="" val="0"/>
+              <ma14:wrappingTextBoxFlag xmlns="" xmlns:ma14="http://schemas.microsoft.com/office/mac/drawingml/2011/main" val="0"/>
             </a:ext>
           </a:extLst>
         </p:spPr>
@@ -33327,7 +33292,7 @@
           </a:prstGeom>
           <a:extLst>
             <a:ext uri="{C572A759-6A51-4108-AA02-DFA0A04FC94B}">
-              <ma14:wrappingTextBoxFlag xmlns:ma14="http://schemas.microsoft.com/office/mac/drawingml/2011/main" xmlns="" val="0"/>
+              <ma14:wrappingTextBoxFlag xmlns="" xmlns:ma14="http://schemas.microsoft.com/office/mac/drawingml/2011/main" val="0"/>
             </a:ext>
           </a:extLst>
         </p:spPr>
@@ -33563,7 +33528,7 @@
           </a:prstGeom>
           <a:extLst>
             <a:ext uri="{C572A759-6A51-4108-AA02-DFA0A04FC94B}">
-              <ma14:wrappingTextBoxFlag xmlns:ma14="http://schemas.microsoft.com/office/mac/drawingml/2011/main" xmlns="" val="0"/>
+              <ma14:wrappingTextBoxFlag xmlns="" xmlns:ma14="http://schemas.microsoft.com/office/mac/drawingml/2011/main" val="0"/>
             </a:ext>
           </a:extLst>
         </p:spPr>
@@ -34907,7 +34872,7 @@
           </a:prstGeom>
           <a:extLst>
             <a:ext uri="{C572A759-6A51-4108-AA02-DFA0A04FC94B}">
-              <ma14:wrappingTextBoxFlag xmlns:ma14="http://schemas.microsoft.com/office/mac/drawingml/2011/main" xmlns="" val="0"/>
+              <ma14:wrappingTextBoxFlag xmlns="" xmlns:ma14="http://schemas.microsoft.com/office/mac/drawingml/2011/main" val="0"/>
             </a:ext>
           </a:extLst>
         </p:spPr>
@@ -35253,7 +35218,7 @@
           </a:prstGeom>
           <a:extLst>
             <a:ext uri="{C572A759-6A51-4108-AA02-DFA0A04FC94B}">
-              <ma14:wrappingTextBoxFlag xmlns:ma14="http://schemas.microsoft.com/office/mac/drawingml/2011/main" xmlns="" val="0"/>
+              <ma14:wrappingTextBoxFlag xmlns="" xmlns:ma14="http://schemas.microsoft.com/office/mac/drawingml/2011/main" val="0"/>
             </a:ext>
           </a:extLst>
         </p:spPr>
@@ -36319,7 +36284,7 @@
           </a:prstGeom>
           <a:extLst>
             <a:ext uri="{C572A759-6A51-4108-AA02-DFA0A04FC94B}">
-              <ma14:wrappingTextBoxFlag xmlns:ma14="http://schemas.microsoft.com/office/mac/drawingml/2011/main" xmlns="" val="0"/>
+              <ma14:wrappingTextBoxFlag xmlns="" xmlns:ma14="http://schemas.microsoft.com/office/mac/drawingml/2011/main" val="0"/>
             </a:ext>
           </a:extLst>
         </p:spPr>
@@ -36747,7 +36712,7 @@
           </a:prstGeom>
           <a:extLst>
             <a:ext uri="{C572A759-6A51-4108-AA02-DFA0A04FC94B}">
-              <ma14:wrappingTextBoxFlag xmlns:ma14="http://schemas.microsoft.com/office/mac/drawingml/2011/main" xmlns="" val="0"/>
+              <ma14:wrappingTextBoxFlag xmlns="" xmlns:ma14="http://schemas.microsoft.com/office/mac/drawingml/2011/main" val="0"/>
             </a:ext>
           </a:extLst>
         </p:spPr>
@@ -37772,7 +37737,7 @@
           </a:prstGeom>
           <a:extLst>
             <a:ext uri="{C572A759-6A51-4108-AA02-DFA0A04FC94B}">
-              <ma14:wrappingTextBoxFlag xmlns:ma14="http://schemas.microsoft.com/office/mac/drawingml/2011/main" xmlns="" val="0"/>
+              <ma14:wrappingTextBoxFlag xmlns="" xmlns:ma14="http://schemas.microsoft.com/office/mac/drawingml/2011/main" val="0"/>
             </a:ext>
           </a:extLst>
         </p:spPr>
@@ -38145,7 +38110,7 @@
           </a:prstGeom>
           <a:extLst>
             <a:ext uri="{C572A759-6A51-4108-AA02-DFA0A04FC94B}">
-              <ma14:wrappingTextBoxFlag xmlns:ma14="http://schemas.microsoft.com/office/mac/drawingml/2011/main" xmlns="" val="0"/>
+              <ma14:wrappingTextBoxFlag xmlns="" xmlns:ma14="http://schemas.microsoft.com/office/mac/drawingml/2011/main" val="0"/>
             </a:ext>
           </a:extLst>
         </p:spPr>
@@ -38649,7 +38614,7 @@
           </a:prstGeom>
           <a:extLst>
             <a:ext uri="{C572A759-6A51-4108-AA02-DFA0A04FC94B}">
-              <ma14:wrappingTextBoxFlag xmlns:ma14="http://schemas.microsoft.com/office/mac/drawingml/2011/main" xmlns="" val="0"/>
+              <ma14:wrappingTextBoxFlag xmlns="" xmlns:ma14="http://schemas.microsoft.com/office/mac/drawingml/2011/main" val="0"/>
             </a:ext>
           </a:extLst>
         </p:spPr>
@@ -38885,7 +38850,7 @@
           </a:prstGeom>
           <a:extLst>
             <a:ext uri="{C572A759-6A51-4108-AA02-DFA0A04FC94B}">
-              <ma14:wrappingTextBoxFlag xmlns:ma14="http://schemas.microsoft.com/office/mac/drawingml/2011/main" xmlns="" val="0"/>
+              <ma14:wrappingTextBoxFlag xmlns="" xmlns:ma14="http://schemas.microsoft.com/office/mac/drawingml/2011/main" val="0"/>
             </a:ext>
           </a:extLst>
         </p:spPr>
@@ -39305,7 +39270,7 @@
           </a:prstGeom>
           <a:extLst>
             <a:ext uri="{C572A759-6A51-4108-AA02-DFA0A04FC94B}">
-              <ma14:wrappingTextBoxFlag xmlns:ma14="http://schemas.microsoft.com/office/mac/drawingml/2011/main" xmlns="" val="0"/>
+              <ma14:wrappingTextBoxFlag xmlns="" xmlns:ma14="http://schemas.microsoft.com/office/mac/drawingml/2011/main" val="0"/>
             </a:ext>
           </a:extLst>
         </p:spPr>
@@ -39711,7 +39676,7 @@
           </a:prstGeom>
           <a:extLst>
             <a:ext uri="{C572A759-6A51-4108-AA02-DFA0A04FC94B}">
-              <ma14:wrappingTextBoxFlag xmlns:ma14="http://schemas.microsoft.com/office/mac/drawingml/2011/main" xmlns="" val="0"/>
+              <ma14:wrappingTextBoxFlag xmlns="" xmlns:ma14="http://schemas.microsoft.com/office/mac/drawingml/2011/main" val="0"/>
             </a:ext>
           </a:extLst>
         </p:spPr>
@@ -40328,7 +40293,7 @@
           </a:prstGeom>
           <a:extLst>
             <a:ext uri="{C572A759-6A51-4108-AA02-DFA0A04FC94B}">
-              <ma14:wrappingTextBoxFlag xmlns:ma14="http://schemas.microsoft.com/office/mac/drawingml/2011/main" xmlns="" val="0"/>
+              <ma14:wrappingTextBoxFlag xmlns="" xmlns:ma14="http://schemas.microsoft.com/office/mac/drawingml/2011/main" val="0"/>
             </a:ext>
           </a:extLst>
         </p:spPr>
@@ -41293,7 +41258,7 @@
           </a:prstGeom>
           <a:extLst>
             <a:ext uri="{C572A759-6A51-4108-AA02-DFA0A04FC94B}">
-              <ma14:wrappingTextBoxFlag xmlns:ma14="http://schemas.microsoft.com/office/mac/drawingml/2011/main" xmlns="" val="0"/>
+              <ma14:wrappingTextBoxFlag xmlns="" xmlns:ma14="http://schemas.microsoft.com/office/mac/drawingml/2011/main" val="0"/>
             </a:ext>
           </a:extLst>
         </p:spPr>
@@ -42223,7 +42188,7 @@
           </a:prstGeom>
           <a:extLst>
             <a:ext uri="{C572A759-6A51-4108-AA02-DFA0A04FC94B}">
-              <ma14:wrappingTextBoxFlag xmlns:ma14="http://schemas.microsoft.com/office/mac/drawingml/2011/main" xmlns="" val="0"/>
+              <ma14:wrappingTextBoxFlag xmlns="" xmlns:ma14="http://schemas.microsoft.com/office/mac/drawingml/2011/main" val="0"/>
             </a:ext>
           </a:extLst>
         </p:spPr>
@@ -43279,7 +43244,7 @@
           </a:prstGeom>
           <a:extLst>
             <a:ext uri="{C572A759-6A51-4108-AA02-DFA0A04FC94B}">
-              <ma14:wrappingTextBoxFlag xmlns:ma14="http://schemas.microsoft.com/office/mac/drawingml/2011/main" xmlns="" val="0"/>
+              <ma14:wrappingTextBoxFlag xmlns="" xmlns:ma14="http://schemas.microsoft.com/office/mac/drawingml/2011/main" val="0"/>
             </a:ext>
           </a:extLst>
         </p:spPr>
@@ -43749,7 +43714,7 @@
           </a:prstGeom>
           <a:extLst>
             <a:ext uri="{C572A759-6A51-4108-AA02-DFA0A04FC94B}">
-              <ma14:wrappingTextBoxFlag xmlns:ma14="http://schemas.microsoft.com/office/mac/drawingml/2011/main" xmlns="" val="0"/>
+              <ma14:wrappingTextBoxFlag xmlns="" xmlns:ma14="http://schemas.microsoft.com/office/mac/drawingml/2011/main" val="0"/>
             </a:ext>
           </a:extLst>
         </p:spPr>
@@ -44292,7 +44257,7 @@
           </a:prstGeom>
           <a:extLst>
             <a:ext uri="{C572A759-6A51-4108-AA02-DFA0A04FC94B}">
-              <ma14:wrappingTextBoxFlag xmlns:ma14="http://schemas.microsoft.com/office/mac/drawingml/2011/main" xmlns="" val="0"/>
+              <ma14:wrappingTextBoxFlag xmlns="" xmlns:ma14="http://schemas.microsoft.com/office/mac/drawingml/2011/main" val="0"/>
             </a:ext>
           </a:extLst>
         </p:spPr>
@@ -45414,7 +45379,7 @@
           </a:prstGeom>
           <a:extLst>
             <a:ext uri="{C572A759-6A51-4108-AA02-DFA0A04FC94B}">
-              <ma14:wrappingTextBoxFlag xmlns:ma14="http://schemas.microsoft.com/office/mac/drawingml/2011/main" xmlns="" val="0"/>
+              <ma14:wrappingTextBoxFlag xmlns="" xmlns:ma14="http://schemas.microsoft.com/office/mac/drawingml/2011/main" val="0"/>
             </a:ext>
           </a:extLst>
         </p:spPr>
@@ -45869,7 +45834,7 @@
           </a:prstGeom>
           <a:extLst>
             <a:ext uri="{C572A759-6A51-4108-AA02-DFA0A04FC94B}">
-              <ma14:wrappingTextBoxFlag xmlns:ma14="http://schemas.microsoft.com/office/mac/drawingml/2011/main" xmlns="" val="0"/>
+              <ma14:wrappingTextBoxFlag xmlns="" xmlns:ma14="http://schemas.microsoft.com/office/mac/drawingml/2011/main" val="0"/>
             </a:ext>
           </a:extLst>
         </p:spPr>
@@ -46105,7 +46070,7 @@
           </a:prstGeom>
           <a:extLst>
             <a:ext uri="{C572A759-6A51-4108-AA02-DFA0A04FC94B}">
-              <ma14:wrappingTextBoxFlag xmlns:ma14="http://schemas.microsoft.com/office/mac/drawingml/2011/main" xmlns="" val="0"/>
+              <ma14:wrappingTextBoxFlag xmlns="" xmlns:ma14="http://schemas.microsoft.com/office/mac/drawingml/2011/main" val="0"/>
             </a:ext>
           </a:extLst>
         </p:spPr>
@@ -46447,7 +46412,7 @@
           </a:prstGeom>
           <a:extLst>
             <a:ext uri="{C572A759-6A51-4108-AA02-DFA0A04FC94B}">
-              <ma14:wrappingTextBoxFlag xmlns:ma14="http://schemas.microsoft.com/office/mac/drawingml/2011/main" xmlns="" val="0"/>
+              <ma14:wrappingTextBoxFlag xmlns="" xmlns:ma14="http://schemas.microsoft.com/office/mac/drawingml/2011/main" val="0"/>
             </a:ext>
           </a:extLst>
         </p:spPr>
@@ -46815,7 +46780,7 @@
           </a:prstGeom>
           <a:extLst>
             <a:ext uri="{C572A759-6A51-4108-AA02-DFA0A04FC94B}">
-              <ma14:wrappingTextBoxFlag xmlns:ma14="http://schemas.microsoft.com/office/mac/drawingml/2011/main" xmlns="" val="0"/>
+              <ma14:wrappingTextBoxFlag xmlns="" xmlns:ma14="http://schemas.microsoft.com/office/mac/drawingml/2011/main" val="0"/>
             </a:ext>
           </a:extLst>
         </p:spPr>
@@ -47240,7 +47205,7 @@
           </a:prstGeom>
           <a:extLst>
             <a:ext uri="{C572A759-6A51-4108-AA02-DFA0A04FC94B}">
-              <ma14:wrappingTextBoxFlag xmlns:ma14="http://schemas.microsoft.com/office/mac/drawingml/2011/main" xmlns="" val="0"/>
+              <ma14:wrappingTextBoxFlag xmlns="" xmlns:ma14="http://schemas.microsoft.com/office/mac/drawingml/2011/main" val="0"/>
             </a:ext>
           </a:extLst>
         </p:spPr>
@@ -47569,7 +47534,7 @@
           </a:prstGeom>
           <a:extLst>
             <a:ext uri="{C572A759-6A51-4108-AA02-DFA0A04FC94B}">
-              <ma14:wrappingTextBoxFlag xmlns:ma14="http://schemas.microsoft.com/office/mac/drawingml/2011/main" xmlns="" val="0"/>
+              <ma14:wrappingTextBoxFlag xmlns="" xmlns:ma14="http://schemas.microsoft.com/office/mac/drawingml/2011/main" val="0"/>
             </a:ext>
           </a:extLst>
         </p:spPr>
@@ -48760,7 +48725,7 @@
           </a:prstGeom>
           <a:extLst>
             <a:ext uri="{C572A759-6A51-4108-AA02-DFA0A04FC94B}">
-              <ma14:wrappingTextBoxFlag xmlns:ma14="http://schemas.microsoft.com/office/mac/drawingml/2011/main" xmlns="" val="0"/>
+              <ma14:wrappingTextBoxFlag xmlns="" xmlns:ma14="http://schemas.microsoft.com/office/mac/drawingml/2011/main" val="0"/>
             </a:ext>
           </a:extLst>
         </p:spPr>
@@ -49276,7 +49241,7 @@
           </a:prstGeom>
           <a:extLst>
             <a:ext uri="{C572A759-6A51-4108-AA02-DFA0A04FC94B}">
-              <ma14:wrappingTextBoxFlag xmlns:ma14="http://schemas.microsoft.com/office/mac/drawingml/2011/main" xmlns="" val="0"/>
+              <ma14:wrappingTextBoxFlag xmlns="" xmlns:ma14="http://schemas.microsoft.com/office/mac/drawingml/2011/main" val="0"/>
             </a:ext>
           </a:extLst>
         </p:spPr>
@@ -49512,7 +49477,7 @@
           </a:prstGeom>
           <a:extLst>
             <a:ext uri="{C572A759-6A51-4108-AA02-DFA0A04FC94B}">
-              <ma14:wrappingTextBoxFlag xmlns:ma14="http://schemas.microsoft.com/office/mac/drawingml/2011/main" xmlns="" val="0"/>
+              <ma14:wrappingTextBoxFlag xmlns="" xmlns:ma14="http://schemas.microsoft.com/office/mac/drawingml/2011/main" val="0"/>
             </a:ext>
           </a:extLst>
         </p:spPr>

</xml_diff>

<commit_message>
Update presentation file on AI in Plant Breeding with new data
</commit_message>
<xml_diff>
--- a/4. Inteligência Artificial e os Dados_Eder/Dados a base de toda IA no melhoramento.pptx
+++ b/4. Inteligência Artificial e os Dados_Eder/Dados a base de toda IA no melhoramento.pptx
@@ -5379,54 +5379,6 @@
               <a:t>‹#›</a:t>
             </a:fld>
             <a:endParaRPr lang="en-US"/>
-          </a:p>
-        </p:txBody>
-      </p:sp>
-      <p:sp>
-        <p:nvSpPr>
-          <p:cNvPr id="3" name="TextBox 2">
-            <a:extLst>
-              <a:ext uri="{FF2B5EF4-FFF2-40B4-BE49-F238E27FC236}">
-                <a16:creationId xmlns:a16="http://schemas.microsoft.com/office/drawing/2014/main" id="{15B5BAA2-43DA-D791-3F32-1BFB9DF1BF5B}"/>
-              </a:ext>
-            </a:extLst>
-          </p:cNvPr>
-          <p:cNvSpPr txBox="1"/>
-          <p:nvPr userDrawn="1">
-            <p:extLst>
-              <p:ext uri="{1162E1C5-73C7-4A58-AE30-91384D911F3F}">
-                <p184:classification xmlns:p184="http://schemas.microsoft.com/office/powerpoint/2018/4/main" val="ftr"/>
-              </p:ext>
-            </p:extLst>
-          </p:nvPr>
-        </p:nvSpPr>
-        <p:spPr>
-          <a:xfrm>
-            <a:off x="10593388" y="6459220"/>
-            <a:ext cx="1592262" cy="335280"/>
-          </a:xfrm>
-          <a:prstGeom prst="rect">
-            <a:avLst/>
-          </a:prstGeom>
-        </p:spPr>
-        <p:txBody>
-          <a:bodyPr horzOverflow="overflow" lIns="0" tIns="0" rIns="0" bIns="0">
-            <a:spAutoFit/>
-          </a:bodyPr>
-          <a:lstStyle/>
-          <a:p>
-            <a:pPr algn="l"/>
-            <a:r>
-              <a:rPr lang="en-US" sz="2200">
-                <a:solidFill>
-                  <a:srgbClr val="FF8939">
-                    <a:alpha val="50000"/>
-                  </a:srgbClr>
-                </a:solidFill>
-                <a:latin typeface="Aptos" panose="020B0004020202020204" pitchFamily="34" charset="0"/>
-              </a:rPr>
-              <a:t>RESTRICTED</a:t>
-            </a:r>
           </a:p>
         </p:txBody>
       </p:sp>

</xml_diff>